<commit_message>
feat(final-delivery): deliver completed SHIFT-MRI research workstation, experiment lab, adapters, and verified deliverables
</commit_message>
<xml_diff>
--- a/docs/submission/final/SHIFT_MRI_Final_Presentation.pptx
+++ b/docs/submission/final/SHIFT_MRI_Final_Presentation.pptx
@@ -3292,7 +3292,7 @@
               </a:defRPr>
             </a:pPr>
             <a:r>
-              <a:t>•   Antigravity Medical Imaging AI &amp; Neuroinformatics Research Consortium</a:t>
+              <a:t>•   Bhavy Garg | School of Computer Science and Engineering, VIT Chennai</a:t>
             </a:r>
           </a:p>
           <a:p>
@@ -3308,7 +3308,7 @@
               </a:defRPr>
             </a:pPr>
             <a:r>
-              <a:t>•   Authoritative Commit: 435daf0 | Local Workstation: RTX PRO 2000 Blackwell</a:t>
+              <a:t>•   Authoritative Commit: 934c86c | Local Workstation: RTX PRO 2000 Blackwell</a:t>
             </a:r>
           </a:p>
           <a:p>
@@ -7014,7 +7014,7 @@
               </a:defRPr>
             </a:pPr>
             <a:r>
-              <a:t>•   Zero-shot external transfer evaluated on multi-site ADNI (N=500, GE/Siemens/Philips 1.5T/3.0T).</a:t>
+              <a:t>•   Zero-shot external transfer evaluated on multi-site ADNI (N=500, Siemens N=370, Philips N=130).</a:t>
             </a:r>
           </a:p>
           <a:p>

</xml_diff>

<commit_message>
feat(release-reconciliation): reconcile all 10 model metrics, resolve TrustGate contradictions, and pass 11 release blocker tests
</commit_message>
<xml_diff>
--- a/docs/submission/final/SHIFT_MRI_Final_Presentation.pptx
+++ b/docs/submission/final/SHIFT_MRI_Final_Presentation.pptx
@@ -4089,7 +4089,7 @@
               </a:defRPr>
             </a:pPr>
             <a:r>
-              <a:t>Design Constraint: Source-locked calibration on OASIS-1 validation to prevent data leakage.</a:t>
+              <a:t>Thresholds: Source rejection tau* = 0.6340 (80th pct validation risk); Feature clipping q_95 = 4.3905 (95th pct distance).</a:t>
             </a:r>
           </a:p>
         </p:txBody>
@@ -4310,7 +4310,7 @@
               </a:defRPr>
             </a:pPr>
             <a:r>
-              <a:t>•   Multi-Model Disagreement Alone: Error detection AUROC = 0.4674, pAURC[0.5, 1.0] = 0.2845.</a:t>
+              <a:t>•   Multi-Model Disagreement Alone: Error detection AUROC = 0.4674, pAURC[0.5, 1.0] = 0.3086.</a:t>
             </a:r>
           </a:p>
           <a:p>
@@ -4660,7 +4660,7 @@
               </a:defRPr>
             </a:pPr>
             <a:r>
-              <a:t>•   Target Saturation: 100% of ADNI samples (500/500) exhibit Mahalanobis distance &gt; q95.</a:t>
+              <a:t>•   Target Saturation &amp; 100% Flagging: 100% of ADNI samples (500/500) exhibit composite risk &gt;= 0.8033 &gt; tau*=0.6340 (all rejected).</a:t>
             </a:r>
           </a:p>
           <a:p>
@@ -5759,7 +5759,7 @@
               </a:defRPr>
             </a:pPr>
             <a:r>
-              <a:t>Takeaway: Selective prediction provides modest clinical gains, but margin alone provides the cleanest signal.</a:t>
+              <a:t>Clinical Safety Warning: TrustGate-accepted scans MUST NOT be interpreted as clinically reliable.</a:t>
             </a:r>
           </a:p>
         </p:txBody>

</xml_diff>